<commit_message>
M18: Sim-Review umgesetzt (sim_review true, Inhalt aktualisiert)
Co-Authored-By: Claude Opus 4.8 <noreply@anthropic.com>
</commit_message>
<xml_diff>
--- a/protected-downloads/praesentation/M18.pptx
+++ b/protected-downloads/praesentation/M18.pptx
@@ -8484,7 +8484,7 @@
                 </a:solidFill>
                 <a:latin typeface="Arial"/>
               </a:rPr>
-              <a:t>  Theorie-Block I</a:t>
+              <a:t>  Theorie-Block I a</a:t>
             </a:r>
             <a:r>
               <a:rPr sz="900">
@@ -8512,7 +8512,7 @@
                 </a:solidFill>
                 <a:latin typeface="Consolas"/>
               </a:rPr>
-              <a:t>00:23       </a:t>
+              <a:t>00:18       </a:t>
             </a:r>
             <a:r>
               <a:rPr sz="1200" b="1">
@@ -8521,7 +8521,7 @@
                 </a:solidFill>
                 <a:latin typeface="Arial"/>
               </a:rPr>
-              <a:t>  Live-Demo</a:t>
+              <a:t>  Theorie-Block I b: DSGVO</a:t>
             </a:r>
             <a:r>
               <a:rPr sz="900">
@@ -8530,7 +8530,7 @@
                 </a:solidFill>
                 <a:latin typeface="Arial"/>
               </a:rPr>
-              <a:t>  ·  Beamer-Demo</a:t>
+              <a:t>  ·  Vortrag + Diskussion</a:t>
             </a:r>
           </a:p>
           <a:p>
@@ -8549,7 +8549,7 @@
                 </a:solidFill>
                 <a:latin typeface="Consolas"/>
               </a:rPr>
-              <a:t>00:38       </a:t>
+              <a:t>00:26       </a:t>
             </a:r>
             <a:r>
               <a:rPr sz="1200" b="1">
@@ -8558,7 +8558,7 @@
                 </a:solidFill>
                 <a:latin typeface="Arial"/>
               </a:rPr>
-              <a:t>  Einzelübung I</a:t>
+              <a:t>  Live-Demo</a:t>
             </a:r>
             <a:r>
               <a:rPr sz="900">
@@ -8567,7 +8567,7 @@
                 </a:solidFill>
                 <a:latin typeface="Arial"/>
               </a:rPr>
-              <a:t>  ·  agree-Einzelarbeit</a:t>
+              <a:t>  ·  Beamer-Demo</a:t>
             </a:r>
           </a:p>
           <a:p>
@@ -8586,7 +8586,7 @@
                 </a:solidFill>
                 <a:latin typeface="Consolas"/>
               </a:rPr>
-              <a:t>01:08       </a:t>
+              <a:t>00:43       </a:t>
             </a:r>
             <a:r>
               <a:rPr sz="1200" b="1">
@@ -8595,7 +8595,7 @@
                 </a:solidFill>
                 <a:latin typeface="Arial"/>
               </a:rPr>
-              <a:t>  Partnercheck</a:t>
+              <a:t>  Einzelübung I</a:t>
             </a:r>
             <a:r>
               <a:rPr sz="900">
@@ -8604,7 +8604,7 @@
                 </a:solidFill>
                 <a:latin typeface="Arial"/>
               </a:rPr>
-              <a:t>  ·  Partnerarbeit</a:t>
+              <a:t>  ·  agree-Einzelarbeit</a:t>
             </a:r>
           </a:p>
           <a:p>
@@ -8632,7 +8632,7 @@
                 </a:solidFill>
                 <a:latin typeface="Arial"/>
               </a:rPr>
-              <a:t>  Transfer-Abschluss</a:t>
+              <a:t>  Partnercheck</a:t>
             </a:r>
             <a:r>
               <a:rPr sz="900">
@@ -8641,7 +8641,7 @@
                 </a:solidFill>
                 <a:latin typeface="Arial"/>
               </a:rPr>
-              <a:t>  ·  Kartenabfrage</a:t>
+              <a:t>  ·  Partnerarbeit</a:t>
             </a:r>
           </a:p>
           <a:p>
@@ -8669,7 +8669,7 @@
                 </a:solidFill>
                 <a:latin typeface="Arial"/>
               </a:rPr>
-              <a:t>  Hinweis Datenqualität</a:t>
+              <a:t>  Transfer-Abschluss</a:t>
             </a:r>
             <a:r>
               <a:rPr sz="900">
@@ -8678,7 +8678,7 @@
                 </a:solidFill>
                 <a:latin typeface="Arial"/>
               </a:rPr>
-              <a:t>  ·  Kurzerklärung</a:t>
+              <a:t>  ·  Kartenabfrage</a:t>
             </a:r>
           </a:p>
           <a:p>
@@ -8697,7 +8697,7 @@
                 </a:solidFill>
                 <a:latin typeface="Consolas"/>
               </a:rPr>
-              <a:t>01:23       </a:t>
+              <a:t>01:24       </a:t>
             </a:r>
             <a:r>
               <a:rPr sz="1200" b="1">
@@ -8706,7 +8706,7 @@
                 </a:solidFill>
                 <a:latin typeface="Arial"/>
               </a:rPr>
-              <a:t>  Kurz-Wrap-up</a:t>
+              <a:t>  Hinweis Datenqualität</a:t>
             </a:r>
             <a:r>
               <a:rPr sz="900">
@@ -8715,7 +8715,7 @@
                 </a:solidFill>
                 <a:latin typeface="Arial"/>
               </a:rPr>
-              <a:t>  ·  Frontal</a:t>
+              <a:t>  ·  Kurzerklärung</a:t>
             </a:r>
           </a:p>
           <a:p>
@@ -8734,7 +8734,7 @@
                 </a:solidFill>
                 <a:latin typeface="Consolas"/>
               </a:rPr>
-              <a:t>01:28       </a:t>
+              <a:t>01:29       </a:t>
             </a:r>
             <a:r>
               <a:rPr sz="1200" b="1">
@@ -8743,7 +8743,7 @@
                 </a:solidFill>
                 <a:latin typeface="Arial"/>
               </a:rPr>
-              <a:t>  Feedbackbogen</a:t>
+              <a:t>  Kurz-Wrap-up</a:t>
             </a:r>
             <a:r>
               <a:rPr sz="900">
@@ -8752,7 +8752,7 @@
                 </a:solidFill>
                 <a:latin typeface="Arial"/>
               </a:rPr>
-              <a:t>  ·  Einzeln</a:t>
+              <a:t>  ·  Frontal</a:t>
             </a:r>
           </a:p>
           <a:p>
@@ -8771,7 +8771,44 @@
                 </a:solidFill>
                 <a:latin typeface="Consolas"/>
               </a:rPr>
-              <a:t>01:30       </a:t>
+              <a:t>01:35       </a:t>
+            </a:r>
+            <a:r>
+              <a:rPr sz="1200" b="1">
+                <a:solidFill>
+                  <a:srgbClr val="3D5466"/>
+                </a:solidFill>
+                <a:latin typeface="Arial"/>
+              </a:rPr>
+              <a:t>  Feedbackbogen</a:t>
+            </a:r>
+            <a:r>
+              <a:rPr sz="900">
+                <a:solidFill>
+                  <a:srgbClr val="78808C"/>
+                </a:solidFill>
+                <a:latin typeface="Arial"/>
+              </a:rPr>
+              <a:t>  ·  Einzeln</a:t>
+            </a:r>
+          </a:p>
+          <a:p>
+            <a:pPr>
+              <a:spcBef>
+                <a:spcPts val="400"/>
+              </a:spcBef>
+              <a:spcAft>
+                <a:spcPts val="100"/>
+              </a:spcAft>
+            </a:pPr>
+            <a:r>
+              <a:rPr sz="900">
+                <a:solidFill>
+                  <a:srgbClr val="78808C"/>
+                </a:solidFill>
+                <a:latin typeface="Consolas"/>
+              </a:rPr>
+              <a:t>01:40       </a:t>
             </a:r>
             <a:r>
               <a:rPr sz="1200" b="1">

</xml_diff>

<commit_message>
TN-PDFs neu: TOC-Qualitaet (einheitliche Schreibung, Nummern-Reste, kurze Titel, kein Container)
Co-Authored-By: Claude Opus 4.8 <noreply@anthropic.com>
</commit_message>
<xml_diff>
--- a/protected-downloads/praesentation/M18.pptx
+++ b/protected-downloads/praesentation/M18.pptx
@@ -5849,7 +5849,7 @@
                 </a:solidFill>
                 <a:latin typeface="Source Serif 4"/>
               </a:rPr>
-              <a:t>AB-1: Mein Bestand – und was ich (noch) nicht sehe: Trigger + Datenlücken</a:t>
+              <a:t>AB-1: Mein Bestand – Trigger + Datenlücken</a:t>
             </a:r>
           </a:p>
         </p:txBody>
@@ -6181,7 +6181,7 @@
                 </a:solidFill>
                 <a:latin typeface="Source Serif 4"/>
               </a:rPr>
-              <a:t>AB-1: Mein Bestand – und was ich (noch) nicht sehe: Trigger + Datenlücken</a:t>
+              <a:t>AB-1: Mein Bestand – Trigger + Datenlücken</a:t>
             </a:r>
           </a:p>
         </p:txBody>

</xml_diff>

<commit_message>
M-Track Batch 3: M18 Deck (Web/Workbook)
Co-Authored-By: Claude Fable 5 <noreply@anthropic.com>
</commit_message>
<xml_diff>
--- a/protected-downloads/praesentation/M18.pptx
+++ b/protected-downloads/praesentation/M18.pptx
@@ -18,7 +18,6 @@
     <p:sldId id="266" r:id="rId18"/>
     <p:sldId id="267" r:id="rId19"/>
     <p:sldId id="268" r:id="rId20"/>
-    <p:sldId id="269" r:id="rId21"/>
   </p:sldIdLst>
   <p:sldSz cx="12188952" cy="6858000" type="screen4x3"/>
   <p:notesSz cx="6858000" cy="9144000"/>
@@ -585,7 +584,7 @@
           <a:lstStyle/>
           <a:p>
             <a:r>
-              <a:t>Siehe Trainerhandbuch (Sektion 3) für Moderationshinweise, Timing und erwartete Teilnehmerreaktionen.</a:t>
+              <a:t>Einstieg: „Wie fühlt sich ein Anruf an, der mit einem echten Anlass beginnt – gegenüber einem Kaltanruf?"</a:t>
             </a:r>
           </a:p>
         </p:txBody>
@@ -655,7 +654,7 @@
           <a:lstStyle/>
           <a:p>
             <a:r>
-              <a:t>Siehe Trainerhandbuch (Sektion 3) für Moderationshinweise, Timing und erwartete Teilnehmerreaktionen.</a:t>
+              <a:t>Kernbotschaft: das Signal sagt, wann und warum – das Gespräch macht der Mensch.</a:t>
             </a:r>
           </a:p>
         </p:txBody>
@@ -725,7 +724,7 @@
           <a:lstStyle/>
           <a:p>
             <a:r>
-              <a:t>Siehe Trainerhandbuch (Sektion 3) für Moderationshinweise, Timing und erwartete Teilnehmerreaktionen.</a:t>
+              <a:t>Jeder Typ hat eine eigene Ansprache-Logik – der lebensereignisbasierte Trigger ist der sensibelste.</a:t>
             </a:r>
           </a:p>
         </p:txBody>
@@ -795,7 +794,12 @@
           <a:lstStyle/>
           <a:p>
             <a:r>
-              <a:t>Siehe Trainerhandbuch (Sektion 3) für Moderationshinweise, Timing und erwartete Teilnehmerreaktionen.</a:t>
+              <a:t>Vor jeder Verbundpartner-Übergabe die Einwilligung prüfen. Transparenz („Mir ist aufgefallen…") schafft Vertrauen.</a:t>
+            </a:r>
+          </a:p>
+          <a:p>
+            <a:r>
+              <a:t>Moderation (HB Sec 3): Wenn TN ohne M17 im Raum sind: Vor der Demo kurz abfragen – „Wer hat M17 noch nicht gemacht?" – und diese TN bitten, sich auf das Mitschauen zu konzentrieren statt parallel mitzunavigieren. Alternativ ein Zweierteam mit einem M17-erfahrenen TN bilden. M17-Abwesenheit ist kein Ausschlussgrund für M18, aber die Demo-Erwartung muss angepasst werden.</a:t>
             </a:r>
           </a:p>
         </p:txBody>
@@ -865,7 +869,7 @@
           <a:lstStyle/>
           <a:p>
             <a:r>
-              <a:t>Siehe Trainerhandbuch (Sektion 3) für Moderationshinweise, Timing und erwartete Teilnehmerreaktionen.</a:t>
+              <a:t>Praxiscase: je Trigger-Typ ein Gespräch – transaktional, ratingbasiert, lebensereignisbasiert. Die Ansprache unterscheidet sich, der menschliche Kern bleibt.</a:t>
             </a:r>
           </a:p>
         </p:txBody>
@@ -935,7 +939,7 @@
           <a:lstStyle/>
           <a:p>
             <a:r>
-              <a:t>Siehe Trainerhandbuch (Sektion 3) für Moderationshinweise, Timing und erwartete Teilnehmerreaktionen.</a:t>
+              <a:t>Überleitung zum Selbstcheck.</a:t>
             </a:r>
           </a:p>
         </p:txBody>
@@ -1005,7 +1009,7 @@
           <a:lstStyle/>
           <a:p>
             <a:r>
-              <a:t>Siehe Trainerhandbuch (Sektion 3) für Moderationshinweise, Timing und erwartete Teilnehmerreaktionen.</a:t>
+              <a:t>Datenqualitäts-Audit und Selbstcheck als Transferanker.</a:t>
             </a:r>
           </a:p>
         </p:txBody>
@@ -4601,7 +4605,7 @@
             <a:avLst/>
           </a:prstGeom>
           <a:solidFill>
-            <a:srgbClr val="EDEDF3"/>
+            <a:srgbClr val="1F2C56"/>
           </a:solidFill>
           <a:ln>
             <a:noFill/>
@@ -4631,57 +4635,14 @@
       </p:sp>
       <p:sp>
         <p:nvSpPr>
-          <p:cNvPr id="3" name="Rectangle 2"/>
-          <p:cNvSpPr/>
-          <p:nvPr/>
-        </p:nvSpPr>
-        <p:spPr>
-          <a:xfrm>
-            <a:off x="0" y="0"/>
-            <a:ext cx="12188952" cy="50292"/>
-          </a:xfrm>
-          <a:prstGeom prst="rect">
-            <a:avLst/>
-          </a:prstGeom>
-          <a:solidFill>
-            <a:srgbClr val="1F2C56"/>
-          </a:solidFill>
-          <a:ln>
-            <a:noFill/>
-          </a:ln>
-        </p:spPr>
-        <p:style>
-          <a:lnRef idx="1">
-            <a:schemeClr val="accent1"/>
-          </a:lnRef>
-          <a:fillRef idx="3">
-            <a:schemeClr val="accent1"/>
-          </a:fillRef>
-          <a:effectRef idx="2">
-            <a:schemeClr val="accent1"/>
-          </a:effectRef>
-          <a:fontRef idx="minor">
-            <a:schemeClr val="lt1"/>
-          </a:fontRef>
-        </p:style>
-        <p:txBody>
-          <a:bodyPr rtlCol="0" anchor="ctr"/>
-          <a:lstStyle/>
-          <a:p>
-            <a:pPr algn="ctr"/>
-          </a:p>
-        </p:txBody>
-      </p:sp>
-      <p:sp>
-        <p:nvSpPr>
-          <p:cNvPr id="4" name="TextBox 3"/>
+          <p:cNvPr id="3" name="TextBox 2"/>
           <p:cNvSpPr txBox="1"/>
           <p:nvPr/>
         </p:nvSpPr>
         <p:spPr>
           <a:xfrm>
-            <a:off x="685800" y="109728"/>
-            <a:ext cx="10817352" cy="228600"/>
+            <a:off x="685800" y="2377440"/>
+            <a:ext cx="10817352" cy="365760"/>
           </a:xfrm>
           <a:prstGeom prst="rect">
             <a:avLst/>
@@ -4696,70 +4657,27 @@
           <a:p>
             <a:pPr algn="l"/>
             <a:r>
-              <a:rPr sz="750">
-                <a:solidFill>
-                  <a:srgbClr val="78808C"/>
+              <a:rPr sz="1200">
+                <a:solidFill>
+                  <a:srgbClr val="D9C089"/>
                 </a:solidFill>
                 <a:latin typeface="Consolas"/>
               </a:rPr>
-              <a:t>M18  ·  INHALT</a:t>
-            </a:r>
-          </a:p>
-        </p:txBody>
-      </p:sp>
-      <p:sp>
-        <p:nvSpPr>
-          <p:cNvPr id="5" name="Rectangle 4"/>
+              <a:t>FALLARBEIT</a:t>
+            </a:r>
+          </a:p>
+        </p:txBody>
+      </p:sp>
+      <p:sp>
+        <p:nvSpPr>
+          <p:cNvPr id="4" name="Rectangle 3"/>
           <p:cNvSpPr/>
           <p:nvPr/>
         </p:nvSpPr>
         <p:spPr>
           <a:xfrm>
-            <a:off x="0" y="1234440"/>
-            <a:ext cx="12188952" cy="12700"/>
-          </a:xfrm>
-          <a:prstGeom prst="rect">
-            <a:avLst/>
-          </a:prstGeom>
-          <a:solidFill>
-            <a:srgbClr val="D8DFE4"/>
-          </a:solidFill>
-          <a:ln>
-            <a:noFill/>
-          </a:ln>
-        </p:spPr>
-        <p:style>
-          <a:lnRef idx="1">
-            <a:schemeClr val="accent1"/>
-          </a:lnRef>
-          <a:fillRef idx="3">
-            <a:schemeClr val="accent1"/>
-          </a:fillRef>
-          <a:effectRef idx="2">
-            <a:schemeClr val="accent1"/>
-          </a:effectRef>
-          <a:fontRef idx="minor">
-            <a:schemeClr val="lt1"/>
-          </a:fontRef>
-        </p:style>
-        <p:txBody>
-          <a:bodyPr rtlCol="0" anchor="ctr"/>
-          <a:lstStyle/>
-          <a:p>
-            <a:pPr algn="ctr"/>
-          </a:p>
-        </p:txBody>
-      </p:sp>
-      <p:sp>
-        <p:nvSpPr>
-          <p:cNvPr id="6" name="Rectangle 5"/>
-          <p:cNvSpPr/>
-          <p:nvPr/>
-        </p:nvSpPr>
-        <p:spPr>
-          <a:xfrm>
-            <a:off x="685800" y="502920"/>
-            <a:ext cx="36576" cy="658368"/>
+            <a:off x="685800" y="2788920"/>
+            <a:ext cx="548640" cy="38100"/>
           </a:xfrm>
           <a:prstGeom prst="rect">
             <a:avLst/>
@@ -4795,14 +4713,14 @@
       </p:sp>
       <p:sp>
         <p:nvSpPr>
-          <p:cNvPr id="7" name="TextBox 6"/>
+          <p:cNvPr id="5" name="TextBox 4"/>
           <p:cNvSpPr txBox="1"/>
           <p:nvPr/>
         </p:nvSpPr>
         <p:spPr>
           <a:xfrm>
-            <a:off x="813816" y="502920"/>
-            <a:ext cx="10634472" cy="685800"/>
+            <a:off x="685800" y="3017520"/>
+            <a:ext cx="10817352" cy="1463040"/>
           </a:xfrm>
           <a:prstGeom prst="rect">
             <a:avLst/>
@@ -4817,27 +4735,27 @@
           <a:p>
             <a:pPr algn="l"/>
             <a:r>
-              <a:rPr sz="2400" b="1" i="0">
-                <a:solidFill>
-                  <a:srgbClr val="1F2C56"/>
+              <a:rPr sz="4000" b="1" i="0">
+                <a:solidFill>
+                  <a:srgbClr val="FFFFFF"/>
                 </a:solidFill>
                 <a:latin typeface="Arial"/>
               </a:rPr>
-              <a:t>Was ist erlaubt – was nicht?</a:t>
-            </a:r>
-          </a:p>
-        </p:txBody>
-      </p:sp>
-      <p:sp>
-        <p:nvSpPr>
-          <p:cNvPr id="8" name="TextBox 7"/>
+              <a:t>Praxiscase</a:t>
+            </a:r>
+          </a:p>
+        </p:txBody>
+      </p:sp>
+      <p:sp>
+        <p:nvSpPr>
+          <p:cNvPr id="6" name="TextBox 5"/>
           <p:cNvSpPr txBox="1"/>
           <p:nvPr/>
         </p:nvSpPr>
         <p:spPr>
           <a:xfrm>
-            <a:off x="685800" y="1417320"/>
-            <a:ext cx="10817352" cy="4892040"/>
+            <a:off x="685800" y="4480560"/>
+            <a:ext cx="8653881" cy="1280160"/>
           </a:xfrm>
           <a:prstGeom prst="rect">
             <a:avLst/>
@@ -4845,141 +4763,34 @@
           <a:noFill/>
         </p:spPr>
         <p:txBody>
-          <a:bodyPr wrap="square" anchor="ctr">
+          <a:bodyPr wrap="square">
             <a:spAutoFit/>
           </a:bodyPr>
           <a:lstStyle/>
           <a:p>
-            <a:pPr marL="190500" indent="-190500">
-              <a:spcBef>
-                <a:spcPts val="400"/>
-              </a:spcBef>
-              <a:spcAft>
-                <a:spcPts val="200"/>
-              </a:spcAft>
-            </a:pPr>
-            <a:r>
-              <a:rPr sz="1300">
-                <a:solidFill>
-                  <a:srgbClr val="3D5466"/>
+            <a:pPr algn="l"/>
+            <a:r>
+              <a:rPr sz="1600" b="0" i="0">
+                <a:solidFill>
+                  <a:srgbClr val="C8D2E6"/>
                 </a:solidFill>
                 <a:latin typeface="Arial"/>
               </a:rPr>
-              <a:t>▸  Kundendaten dürfen für Vertriebszwecke genutzt werden, wenn:</a:t>
-            </a:r>
-          </a:p>
-          <a:p>
-            <a:pPr marL="190500" indent="-190500">
-              <a:spcBef>
-                <a:spcPts val="400"/>
-              </a:spcBef>
-              <a:spcAft>
-                <a:spcPts val="200"/>
-              </a:spcAft>
-            </a:pPr>
-            <a:r>
-              <a:rPr sz="1300">
-                <a:solidFill>
-                  <a:srgbClr val="3D5466"/>
-                </a:solidFill>
-                <a:latin typeface="Arial"/>
-              </a:rPr>
-              <a:t>▸  Eine Rechtsgrundlage besteht (Art. 6 DSGVO): Bei Bankbeziehungen gilt üblicherweise das berechtigte Interesse (Art. 6 Abs. 1 lit. f DSGVO) für Bestandskundenpflege und -beratung</a:t>
-            </a:r>
-          </a:p>
-          <a:p>
-            <a:pPr marL="190500" indent="-190500">
-              <a:spcBef>
-                <a:spcPts val="400"/>
-              </a:spcBef>
-              <a:spcAft>
-                <a:spcPts val="200"/>
-              </a:spcAft>
-            </a:pPr>
-            <a:r>
-              <a:rPr sz="1300">
-                <a:solidFill>
-                  <a:srgbClr val="3D5466"/>
-                </a:solidFill>
-                <a:latin typeface="Arial"/>
-              </a:rPr>
-              <a:t>▸  Die Nutzung dem Kunden gegenüber transparent gemacht wird (Datenschutzerklärung)</a:t>
-            </a:r>
-          </a:p>
-          <a:p>
-            <a:pPr marL="190500" indent="-190500">
-              <a:spcBef>
-                <a:spcPts val="400"/>
-              </a:spcBef>
-              <a:spcAft>
-                <a:spcPts val="200"/>
-              </a:spcAft>
-            </a:pPr>
-            <a:r>
-              <a:rPr sz="1300">
-                <a:solidFill>
-                  <a:srgbClr val="3D5466"/>
-                </a:solidFill>
-                <a:latin typeface="Arial"/>
-              </a:rPr>
-              <a:t>▸  Keine sensiblen Daten (Art. 9 DSGVO) ohne explizite Einwilligung verarbeitet werden</a:t>
-            </a:r>
-          </a:p>
-        </p:txBody>
-      </p:sp>
-      <p:sp>
-        <p:nvSpPr>
-          <p:cNvPr id="9" name="Rectangle 8"/>
-          <p:cNvSpPr/>
-          <p:nvPr/>
-        </p:nvSpPr>
-        <p:spPr>
-          <a:xfrm>
-            <a:off x="0" y="6510528"/>
-            <a:ext cx="12188952" cy="347472"/>
-          </a:xfrm>
-          <a:prstGeom prst="rect">
-            <a:avLst/>
-          </a:prstGeom>
-          <a:solidFill>
-            <a:srgbClr val="0A1937"/>
-          </a:solidFill>
-          <a:ln>
-            <a:noFill/>
-          </a:ln>
-        </p:spPr>
-        <p:style>
-          <a:lnRef idx="1">
-            <a:schemeClr val="accent1"/>
-          </a:lnRef>
-          <a:fillRef idx="3">
-            <a:schemeClr val="accent1"/>
-          </a:fillRef>
-          <a:effectRef idx="2">
-            <a:schemeClr val="accent1"/>
-          </a:effectRef>
-          <a:fontRef idx="minor">
-            <a:schemeClr val="lt1"/>
-          </a:fontRef>
-        </p:style>
-        <p:txBody>
-          <a:bodyPr rtlCol="0" anchor="ctr"/>
-          <a:lstStyle/>
-          <a:p>
-            <a:pPr algn="ctr"/>
-          </a:p>
-        </p:txBody>
-      </p:sp>
-      <p:sp>
-        <p:nvSpPr>
-          <p:cNvPr id="10" name="TextBox 9"/>
+              <a:t>Aus drei Triggern drei passende Gespräche machen.</a:t>
+            </a:r>
+          </a:p>
+        </p:txBody>
+      </p:sp>
+      <p:sp>
+        <p:nvSpPr>
+          <p:cNvPr id="7" name="TextBox 6"/>
           <p:cNvSpPr txBox="1"/>
           <p:nvPr/>
         </p:nvSpPr>
         <p:spPr>
           <a:xfrm>
-            <a:off x="685800" y="6583680"/>
-            <a:ext cx="6490411" cy="256032"/>
+            <a:off x="685800" y="6355080"/>
+            <a:ext cx="10817352" cy="274320"/>
           </a:xfrm>
           <a:prstGeom prst="rect">
             <a:avLst/>
@@ -4996,7 +4807,7 @@
             <a:r>
               <a:rPr sz="700">
                 <a:solidFill>
-                  <a:srgbClr val="A0B4D2"/>
+                  <a:srgbClr val="8CA0C3"/>
                 </a:solidFill>
                 <a:latin typeface="Consolas"/>
               </a:rPr>
@@ -5139,7 +4950,7 @@
                 </a:solidFill>
                 <a:latin typeface="Consolas"/>
               </a:rPr>
-              <a:t>M18  ·  INHALT</a:t>
+              <a:t>M18  ·  ARBEITSBLATT</a:t>
             </a:r>
           </a:p>
         </p:txBody>
@@ -5260,7 +5071,7 @@
                 </a:solidFill>
                 <a:latin typeface="Arial"/>
               </a:rPr>
-              <a:t>Transparenz als Vertrauensmoment</a:t>
+              <a:t>Drei Trigger, drei Gespräche bearbeiten</a:t>
             </a:r>
           </a:p>
         </p:txBody>
@@ -5273,8 +5084,8 @@
         </p:nvSpPr>
         <p:spPr>
           <a:xfrm>
-            <a:off x="685800" y="1417320"/>
-            <a:ext cx="10817352" cy="4892040"/>
+            <a:off x="685800" y="1554480"/>
+            <a:ext cx="10817352" cy="3840480"/>
           </a:xfrm>
           <a:prstGeom prst="rect">
             <a:avLst/>
@@ -5296,13 +5107,13 @@
               </a:spcAft>
             </a:pPr>
             <a:r>
-              <a:rPr sz="1300">
+              <a:rPr sz="1400">
                 <a:solidFill>
                   <a:srgbClr val="3D5466"/>
                 </a:solidFill>
                 <a:latin typeface="Arial"/>
               </a:rPr>
-              <a:t>▸  ## 4.5 Praxiscase: Drei Trigger, drei Gespräche</a:t>
+              <a:t>▸  Identifizieren Sie in Ihrem Bestand Trigger und Datenlücken (AB-1).</a:t>
             </a:r>
           </a:p>
           <a:p>
@@ -5315,13 +5126,13 @@
               </a:spcAft>
             </a:pPr>
             <a:r>
-              <a:rPr sz="1300">
+              <a:rPr sz="1400">
                 <a:solidFill>
                   <a:srgbClr val="3D5466"/>
                 </a:solidFill>
                 <a:latin typeface="Arial"/>
               </a:rPr>
-              <a:t>▸  Ausgangssituation</a:t>
+              <a:t>▸  Führen Sie ein Datenqualitäts-Audit Ihrer Top-10-Kunden durch (AB-2).</a:t>
             </a:r>
           </a:p>
           <a:p>
@@ -5334,191 +5145,98 @@
               </a:spcAft>
             </a:pPr>
             <a:r>
-              <a:rPr sz="1300">
+              <a:rPr sz="1400">
                 <a:solidFill>
                   <a:srgbClr val="3D5466"/>
                 </a:solidFill>
                 <a:latin typeface="Arial"/>
               </a:rPr>
-              <a:t>▸  Beraterin Anna Schreiber hat 38 Firmenkunden. Sie etabliert eine neue Montagsroutine: 20 Minuten agree-Triggerliste durcharbeiten. Was findet sie in der ersten Woche?</a:t>
-            </a:r>
-          </a:p>
-          <a:p>
-            <a:pPr marL="190500" indent="-190500">
-              <a:spcBef>
-                <a:spcPts val="400"/>
-              </a:spcBef>
-              <a:spcAft>
-                <a:spcPts val="200"/>
-              </a:spcAft>
-            </a:pPr>
-            <a:r>
-              <a:rPr sz="1300">
-                <a:solidFill>
-                  <a:srgbClr val="3D5466"/>
+              <a:t>▸  Entwickeln Sie zu drei Triggern je einen passenden, DSGVO-konformen Gesprächseinstieg.</a:t>
+            </a:r>
+          </a:p>
+        </p:txBody>
+      </p:sp>
+      <p:sp>
+        <p:nvSpPr>
+          <p:cNvPr id="9" name="Rectangle 8"/>
+          <p:cNvSpPr/>
+          <p:nvPr/>
+        </p:nvSpPr>
+        <p:spPr>
+          <a:xfrm>
+            <a:off x="685800" y="5486400"/>
+            <a:ext cx="10817352" cy="640080"/>
+          </a:xfrm>
+          <a:prstGeom prst="rect">
+            <a:avLst/>
+          </a:prstGeom>
+          <a:solidFill>
+            <a:srgbClr val="1F2C56"/>
+          </a:solidFill>
+          <a:ln>
+            <a:noFill/>
+          </a:ln>
+        </p:spPr>
+        <p:style>
+          <a:lnRef idx="1">
+            <a:schemeClr val="accent1"/>
+          </a:lnRef>
+          <a:fillRef idx="3">
+            <a:schemeClr val="accent1"/>
+          </a:fillRef>
+          <a:effectRef idx="2">
+            <a:schemeClr val="accent1"/>
+          </a:effectRef>
+          <a:fontRef idx="minor">
+            <a:schemeClr val="lt1"/>
+          </a:fontRef>
+        </p:style>
+        <p:txBody>
+          <a:bodyPr rtlCol="0" anchor="ctr"/>
+          <a:lstStyle/>
+          <a:p>
+            <a:pPr algn="ctr"/>
+          </a:p>
+        </p:txBody>
+      </p:sp>
+      <p:sp>
+        <p:nvSpPr>
+          <p:cNvPr id="10" name="TextBox 9"/>
+          <p:cNvSpPr txBox="1"/>
+          <p:nvPr/>
+        </p:nvSpPr>
+        <p:spPr>
+          <a:xfrm>
+            <a:off x="868680" y="5596128"/>
+            <a:ext cx="10451592" cy="457200"/>
+          </a:xfrm>
+          <a:prstGeom prst="rect">
+            <a:avLst/>
+          </a:prstGeom>
+          <a:noFill/>
+        </p:spPr>
+        <p:txBody>
+          <a:bodyPr wrap="square">
+            <a:spAutoFit/>
+          </a:bodyPr>
+          <a:lstStyle/>
+          <a:p>
+            <a:pPr algn="l"/>
+            <a:r>
+              <a:rPr sz="1300" b="1" i="0">
+                <a:solidFill>
+                  <a:srgbClr val="FFFFFF"/>
                 </a:solidFill>
                 <a:latin typeface="Arial"/>
               </a:rPr>
-              <a:t>▸  Trigger 1: Transaktional – Auslandszahlung erstmals aufgetaucht</a:t>
-            </a:r>
-          </a:p>
-          <a:p>
-            <a:pPr marL="190500" indent="-190500">
-              <a:spcBef>
-                <a:spcPts val="400"/>
-              </a:spcBef>
-              <a:spcAft>
-                <a:spcPts val="200"/>
-              </a:spcAft>
-            </a:pPr>
-            <a:r>
-              <a:rPr sz="1300">
-                <a:solidFill>
-                  <a:srgbClr val="3D5466"/>
-                </a:solidFill>
-                <a:latin typeface="Arial"/>
-              </a:rPr>
-              <a:t>▸  Trigger 2: Ratingbasiert – Prolongation in 5 Monaten</a:t>
-            </a:r>
-          </a:p>
-          <a:p>
-            <a:pPr marL="190500" indent="-190500">
-              <a:spcBef>
-                <a:spcPts val="400"/>
-              </a:spcBef>
-              <a:spcAft>
-                <a:spcPts val="200"/>
-              </a:spcAft>
-            </a:pPr>
-            <a:r>
-              <a:rPr sz="1300">
-                <a:solidFill>
-                  <a:srgbClr val="3D5466"/>
-                </a:solidFill>
-                <a:latin typeface="Arial"/>
-              </a:rPr>
-              <a:t>▸  Trigger 3: Lebensereignis – Gesellschafterin 58 Jahre</a:t>
-            </a:r>
-          </a:p>
-          <a:p>
-            <a:pPr marL="190500" indent="-190500">
-              <a:spcBef>
-                <a:spcPts val="400"/>
-              </a:spcBef>
-              <a:spcAft>
-                <a:spcPts val="200"/>
-              </a:spcAft>
-            </a:pPr>
-            <a:r>
-              <a:rPr sz="1300">
-                <a:solidFill>
-                  <a:srgbClr val="3D5466"/>
-                </a:solidFill>
-                <a:latin typeface="Arial"/>
-              </a:rPr>
-              <a:t>▸  Ergebnis in 4 Wochen</a:t>
-            </a:r>
-          </a:p>
-          <a:p>
-            <a:pPr marL="190500" indent="-190500">
-              <a:spcBef>
-                <a:spcPts val="400"/>
-              </a:spcBef>
-              <a:spcAft>
-                <a:spcPts val="200"/>
-              </a:spcAft>
-            </a:pPr>
-            <a:r>
-              <a:rPr sz="1300">
-                <a:solidFill>
-                  <a:srgbClr val="3D5466"/>
-                </a:solidFill>
-                <a:latin typeface="Arial"/>
-              </a:rPr>
-              <a:t>▸  Anna hat mit drei Triggern drei Gespräche initiiert – alle mit konkretem Ergebnis. Kein Gespräch war ein „Kaltanruf". Alle hatten eine evidenzbasierte Gesprächseröffnung.</a:t>
-            </a:r>
-          </a:p>
-          <a:p>
-            <a:pPr marL="190500" indent="-190500">
-              <a:spcBef>
-                <a:spcPts val="400"/>
-              </a:spcBef>
-              <a:spcAft>
-                <a:spcPts val="200"/>
-              </a:spcAft>
-            </a:pPr>
-            <a:r>
-              <a:rPr sz="1300">
-                <a:solidFill>
-                  <a:srgbClr val="3D5466"/>
-                </a:solidFill>
-                <a:latin typeface="Arial"/>
-              </a:rPr>
-              <a:t>▸  Reflexionsfragen</a:t>
-            </a:r>
-          </a:p>
-          <a:p>
-            <a:pPr marL="190500" indent="-190500">
-              <a:spcBef>
-                <a:spcPts val="400"/>
-              </a:spcBef>
-              <a:spcAft>
-                <a:spcPts val="200"/>
-              </a:spcAft>
-            </a:pPr>
-            <a:r>
-              <a:rPr sz="1300">
-                <a:solidFill>
-                  <a:srgbClr val="3D5466"/>
-                </a:solidFill>
-                <a:latin typeface="Arial"/>
-              </a:rPr>
-              <a:t>▸  Welche der drei Trigger-Typen ist in Ihrem Bestand am häufigsten verfügbar?</a:t>
-            </a:r>
-          </a:p>
-          <a:p>
-            <a:pPr marL="190500" indent="-190500">
-              <a:spcBef>
-                <a:spcPts val="400"/>
-              </a:spcBef>
-              <a:spcAft>
-                <a:spcPts val="200"/>
-              </a:spcAft>
-            </a:pPr>
-            <a:r>
-              <a:rPr sz="1300">
-                <a:solidFill>
-                  <a:srgbClr val="3D5466"/>
-                </a:solidFill>
-                <a:latin typeface="Arial"/>
-              </a:rPr>
-              <a:t>▸  Wo in agree würden Sie morgen früh mit der Triggersuche anfangen?</a:t>
-            </a:r>
-          </a:p>
-          <a:p>
-            <a:pPr marL="190500" indent="-190500">
-              <a:spcBef>
-                <a:spcPts val="400"/>
-              </a:spcBef>
-              <a:spcAft>
-                <a:spcPts val="200"/>
-              </a:spcAft>
-            </a:pPr>
-            <a:r>
-              <a:rPr sz="1300">
-                <a:solidFill>
-                  <a:srgbClr val="3D5466"/>
-                </a:solidFill>
-                <a:latin typeface="Arial"/>
-              </a:rPr>
-              <a:t>▸  Wie würden Sie dem Kunden Becker erklären, warum Sie angerufen haben – ohne dass er sich überwacht fühlt?</a:t>
-            </a:r>
-          </a:p>
-        </p:txBody>
-      </p:sp>
-      <p:sp>
-        <p:nvSpPr>
-          <p:cNvPr id="9" name="Rectangle 8"/>
+              <a:t>→  Bearbeitung im Teilnehmer-Workbook (Arbeitsblatt mit Ausfüllfeldern)</a:t>
+            </a:r>
+          </a:p>
+        </p:txBody>
+      </p:sp>
+      <p:sp>
+        <p:nvSpPr>
+          <p:cNvPr id="11" name="Rectangle 10"/>
           <p:cNvSpPr/>
           <p:nvPr/>
         </p:nvSpPr>
@@ -5561,7 +5279,7 @@
       </p:sp>
       <p:sp>
         <p:nvSpPr>
-          <p:cNvPr id="10" name="TextBox 9"/>
+          <p:cNvPr id="12" name="TextBox 11"/>
           <p:cNvSpPr txBox="1"/>
           <p:nvPr/>
         </p:nvSpPr>
@@ -5849,7 +5567,7 @@
                 </a:solidFill>
                 <a:latin typeface="Arial"/>
               </a:rPr>
-              <a:t>AB-1: Mein Bestand – Trigger + Datenlücken</a:t>
+              <a:t>Prinzip dieses Moduls</a:t>
             </a:r>
           </a:p>
         </p:txBody>
@@ -5875,6 +5593,25 @@
             <a:spAutoFit/>
           </a:bodyPr>
           <a:lstStyle/>
+          <a:p>
+            <a:pPr marL="177800" indent="-177800">
+              <a:spcBef>
+                <a:spcPts val="600"/>
+              </a:spcBef>
+              <a:spcAft>
+                <a:spcPts val="200"/>
+              </a:spcAft>
+            </a:pPr>
+            <a:r>
+              <a:rPr sz="1200" i="1">
+                <a:solidFill>
+                  <a:srgbClr val="3D5466"/>
+                </a:solidFill>
+                <a:latin typeface="Arial"/>
+              </a:rPr>
+              <a:t>→  Ein Datenpunkt öffnet die Tür – das Gespräch bleibt menschlich.</a:t>
+            </a:r>
+          </a:p>
           <a:p>
             <a:pPr marL="190500" indent="-190500">
               <a:spcBef>
@@ -5891,45 +5628,7 @@
                 </a:solidFill>
                 <a:latin typeface="Arial"/>
               </a:rPr>
-              <a:t>▸  (Nutzen Sie die Priorisierungstabelle aus Sec 4.6, um Ihren wirkungsvollsten Trigger zu bestimmen)</a:t>
-            </a:r>
-          </a:p>
-          <a:p>
-            <a:pPr marL="190500" indent="-190500">
-              <a:spcBef>
-                <a:spcPts val="400"/>
-              </a:spcBef>
-              <a:spcAft>
-                <a:spcPts val="200"/>
-              </a:spcAft>
-            </a:pPr>
-            <a:r>
-              <a:rPr sz="1300">
-                <a:solidFill>
-                  <a:srgbClr val="3D5466"/>
-                </a:solidFill>
-                <a:latin typeface="Arial"/>
-              </a:rPr>
-              <a:t>▸  Ergänzen Sie für Ihren Bestand die relevantesten Trigger je Typ:</a:t>
-            </a:r>
-          </a:p>
-          <a:p>
-            <a:pPr marL="190500" indent="-190500">
-              <a:spcBef>
-                <a:spcPts val="400"/>
-              </a:spcBef>
-              <a:spcAft>
-                <a:spcPts val="200"/>
-              </a:spcAft>
-            </a:pPr>
-            <a:r>
-              <a:rPr sz="1300">
-                <a:solidFill>
-                  <a:srgbClr val="3D5466"/>
-                </a:solidFill>
-                <a:latin typeface="Arial"/>
-              </a:rPr>
-              <a:t>▸  Mein wirkungsvollster Trigger für die nächsten 4 Wochen:</a:t>
+              <a:t>▸  Trigger aus agree machen aus dem Kaltanruf einen Anlass; die Beziehung entsteht trotzdem am Telefon, nicht in der Software.</a:t>
             </a:r>
           </a:p>
         </p:txBody>
@@ -6045,7 +5744,7 @@
             <a:avLst/>
           </a:prstGeom>
           <a:solidFill>
-            <a:srgbClr val="FFFFFF"/>
+            <a:srgbClr val="EDEDF3"/>
           </a:solidFill>
           <a:ln>
             <a:noFill/>
@@ -6146,43 +5845,51 @@
                 </a:solidFill>
                 <a:latin typeface="Consolas"/>
               </a:rPr>
-              <a:t>M18  ·  ÜBERSICHT</a:t>
-            </a:r>
-          </a:p>
-        </p:txBody>
-      </p:sp>
-      <p:sp>
-        <p:nvSpPr>
-          <p:cNvPr id="5" name="TextBox 4"/>
-          <p:cNvSpPr txBox="1"/>
-          <p:nvPr/>
-        </p:nvSpPr>
-        <p:spPr>
-          <a:xfrm>
-            <a:off x="685800" y="502920"/>
-            <a:ext cx="10817352" cy="594360"/>
-          </a:xfrm>
-          <a:prstGeom prst="rect">
-            <a:avLst/>
-          </a:prstGeom>
-          <a:noFill/>
-        </p:spPr>
-        <p:txBody>
-          <a:bodyPr wrap="square">
-            <a:spAutoFit/>
-          </a:bodyPr>
-          <a:lstStyle/>
-          <a:p>
-            <a:pPr algn="l"/>
-            <a:r>
-              <a:rPr sz="2000" b="1" i="0">
-                <a:solidFill>
-                  <a:srgbClr val="1F2C56"/>
-                </a:solidFill>
-                <a:latin typeface="Arial"/>
-              </a:rPr>
-              <a:t>AB-1: Mein Bestand – Trigger + Datenlücken</a:t>
-            </a:r>
+              <a:t>M18  ·  INHALT</a:t>
+            </a:r>
+          </a:p>
+        </p:txBody>
+      </p:sp>
+      <p:sp>
+        <p:nvSpPr>
+          <p:cNvPr id="5" name="Rectangle 4"/>
+          <p:cNvSpPr/>
+          <p:nvPr/>
+        </p:nvSpPr>
+        <p:spPr>
+          <a:xfrm>
+            <a:off x="0" y="1234440"/>
+            <a:ext cx="12188952" cy="12700"/>
+          </a:xfrm>
+          <a:prstGeom prst="rect">
+            <a:avLst/>
+          </a:prstGeom>
+          <a:solidFill>
+            <a:srgbClr val="D8DFE4"/>
+          </a:solidFill>
+          <a:ln>
+            <a:noFill/>
+          </a:ln>
+        </p:spPr>
+        <p:style>
+          <a:lnRef idx="1">
+            <a:schemeClr val="accent1"/>
+          </a:lnRef>
+          <a:fillRef idx="3">
+            <a:schemeClr val="accent1"/>
+          </a:fillRef>
+          <a:effectRef idx="2">
+            <a:schemeClr val="accent1"/>
+          </a:effectRef>
+          <a:fontRef idx="minor">
+            <a:schemeClr val="lt1"/>
+          </a:fontRef>
+        </p:style>
+        <p:txBody>
+          <a:bodyPr rtlCol="0" anchor="ctr"/>
+          <a:lstStyle/>
+          <a:p>
+            <a:pPr algn="ctr"/>
           </a:p>
         </p:txBody>
       </p:sp>
@@ -6194,8 +5901,8 @@
         </p:nvSpPr>
         <p:spPr>
           <a:xfrm>
-            <a:off x="685800" y="1143000"/>
-            <a:ext cx="10817352" cy="25400"/>
+            <a:off x="685800" y="502920"/>
+            <a:ext cx="36576" cy="658368"/>
           </a:xfrm>
           <a:prstGeom prst="rect">
             <a:avLst/>
@@ -6229,391 +5936,124 @@
           </a:p>
         </p:txBody>
       </p:sp>
-      <p:graphicFrame>
-        <p:nvGraphicFramePr>
-          <p:cNvPr id="7" name="Table 6"/>
-          <p:cNvGraphicFramePr>
-            <a:graphicFrameLocks noGrp="1"/>
-          </p:cNvGraphicFramePr>
-          <p:nvPr/>
-        </p:nvGraphicFramePr>
-        <p:xfrm>
-          <a:off x="685800" y="1417320"/>
-          <a:ext cx="10817352" cy="2688336"/>
-        </p:xfrm>
-        <a:graphic>
-          <a:graphicData uri="http://schemas.openxmlformats.org/drawingml/2006/table">
-            <a:tbl>
-              <a:tblPr firstRow="1" bandRow="1">
-                <a:tableStyleId>{5C22544A-7EE6-4342-B048-85BDC9FD1C3A}</a:tableStyleId>
-              </a:tblPr>
-              <a:tblGrid>
-                <a:gridCol w="2704338"/>
-                <a:gridCol w="2704338"/>
-                <a:gridCol w="2704338"/>
-                <a:gridCol w="2704338"/>
-              </a:tblGrid>
-              <a:tr h="384048">
-                <a:tc>
-                  <a:txBody>
-                    <a:bodyPr/>
-                    <a:lstStyle/>
-                    <a:p>
-                      <a:r>
-                        <a:rPr sz="1100" b="1">
-                          <a:solidFill>
-                            <a:srgbClr val="FFFFFF"/>
-                          </a:solidFill>
-                          <a:latin typeface="Arial"/>
-                        </a:rPr>
-                        <a:t>Trigger-Typ</a:t>
-                      </a:r>
-                    </a:p>
-                  </a:txBody>
-                  <a:tcPr>
-                    <a:solidFill>
-                      <a:srgbClr val="1F2C56"/>
-                    </a:solidFill>
-                  </a:tcPr>
-                </a:tc>
-                <a:tc>
-                  <a:txBody>
-                    <a:bodyPr/>
-                    <a:lstStyle/>
-                    <a:p>
-                      <a:r>
-                        <a:rPr sz="1100" b="1">
-                          <a:solidFill>
-                            <a:srgbClr val="FFFFFF"/>
-                          </a:solidFill>
-                          <a:latin typeface="Arial"/>
-                        </a:rPr>
-                        <a:t>Datensignal</a:t>
-                      </a:r>
-                    </a:p>
-                  </a:txBody>
-                  <a:tcPr>
-                    <a:solidFill>
-                      <a:srgbClr val="1F2C56"/>
-                    </a:solidFill>
-                  </a:tcPr>
-                </a:tc>
-                <a:tc>
-                  <a:txBody>
-                    <a:bodyPr/>
-                    <a:lstStyle/>
-                    <a:p>
-                      <a:r>
-                        <a:rPr sz="1100" b="1">
-                          <a:solidFill>
-                            <a:srgbClr val="FFFFFF"/>
-                          </a:solidFill>
-                          <a:latin typeface="Arial"/>
-                        </a:rPr>
-                        <a:t>agree-Quelle</a:t>
-                      </a:r>
-                    </a:p>
-                  </a:txBody>
-                  <a:tcPr>
-                    <a:solidFill>
-                      <a:srgbClr val="1F2C56"/>
-                    </a:solidFill>
-                  </a:tcPr>
-                </a:tc>
-                <a:tc>
-                  <a:txBody>
-                    <a:bodyPr/>
-                    <a:lstStyle/>
-                    <a:p>
-                      <a:r>
-                        <a:rPr sz="1100" b="1">
-                          <a:solidFill>
-                            <a:srgbClr val="FFFFFF"/>
-                          </a:solidFill>
-                          <a:latin typeface="Arial"/>
-                        </a:rPr>
-                        <a:t>Möglicher Bedarf</a:t>
-                      </a:r>
-                    </a:p>
-                  </a:txBody>
-                  <a:tcPr>
-                    <a:solidFill>
-                      <a:srgbClr val="1F2C56"/>
-                    </a:solidFill>
-                  </a:tcPr>
-                </a:tc>
-              </a:tr>
-              <a:tr h="384048">
-                <a:tc>
-                  <a:txBody>
-                    <a:bodyPr/>
-                    <a:lstStyle/>
-                    <a:p>
-                      <a:r>
-                        <a:rPr sz="1050">
-                          <a:solidFill>
-                            <a:srgbClr val="3D5466"/>
-                          </a:solidFill>
-                          <a:latin typeface="Arial"/>
-                        </a:rPr>
-                        <a:t>Transaktional</a:t>
-                      </a:r>
-                    </a:p>
-                  </a:txBody>
-                  <a:tcPr/>
-                </a:tc>
-                <a:tc>
-                  <a:txBody>
-                    <a:bodyPr/>
-                    <a:lstStyle/>
-                    <a:p/>
-                  </a:txBody>
-                  <a:tcPr/>
-                </a:tc>
-                <a:tc>
-                  <a:txBody>
-                    <a:bodyPr/>
-                    <a:lstStyle/>
-                    <a:p/>
-                  </a:txBody>
-                  <a:tcPr/>
-                </a:tc>
-                <a:tc>
-                  <a:txBody>
-                    <a:bodyPr/>
-                    <a:lstStyle/>
-                    <a:p/>
-                  </a:txBody>
-                  <a:tcPr/>
-                </a:tc>
-              </a:tr>
-              <a:tr h="384048">
-                <a:tc>
-                  <a:txBody>
-                    <a:bodyPr/>
-                    <a:lstStyle/>
-                    <a:p>
-                      <a:r>
-                        <a:rPr sz="1050">
-                          <a:solidFill>
-                            <a:srgbClr val="3D5466"/>
-                          </a:solidFill>
-                          <a:latin typeface="Arial"/>
-                        </a:rPr>
-                        <a:t>Transaktional</a:t>
-                      </a:r>
-                    </a:p>
-                  </a:txBody>
-                  <a:tcPr/>
-                </a:tc>
-                <a:tc>
-                  <a:txBody>
-                    <a:bodyPr/>
-                    <a:lstStyle/>
-                    <a:p/>
-                  </a:txBody>
-                  <a:tcPr/>
-                </a:tc>
-                <a:tc>
-                  <a:txBody>
-                    <a:bodyPr/>
-                    <a:lstStyle/>
-                    <a:p/>
-                  </a:txBody>
-                  <a:tcPr/>
-                </a:tc>
-                <a:tc>
-                  <a:txBody>
-                    <a:bodyPr/>
-                    <a:lstStyle/>
-                    <a:p/>
-                  </a:txBody>
-                  <a:tcPr/>
-                </a:tc>
-              </a:tr>
-              <a:tr h="384048">
-                <a:tc>
-                  <a:txBody>
-                    <a:bodyPr/>
-                    <a:lstStyle/>
-                    <a:p>
-                      <a:r>
-                        <a:rPr sz="1050">
-                          <a:solidFill>
-                            <a:srgbClr val="3D5466"/>
-                          </a:solidFill>
-                          <a:latin typeface="Arial"/>
-                        </a:rPr>
-                        <a:t>Ratingbasiert</a:t>
-                      </a:r>
-                    </a:p>
-                  </a:txBody>
-                  <a:tcPr/>
-                </a:tc>
-                <a:tc>
-                  <a:txBody>
-                    <a:bodyPr/>
-                    <a:lstStyle/>
-                    <a:p/>
-                  </a:txBody>
-                  <a:tcPr/>
-                </a:tc>
-                <a:tc>
-                  <a:txBody>
-                    <a:bodyPr/>
-                    <a:lstStyle/>
-                    <a:p/>
-                  </a:txBody>
-                  <a:tcPr/>
-                </a:tc>
-                <a:tc>
-                  <a:txBody>
-                    <a:bodyPr/>
-                    <a:lstStyle/>
-                    <a:p/>
-                  </a:txBody>
-                  <a:tcPr/>
-                </a:tc>
-              </a:tr>
-              <a:tr h="384048">
-                <a:tc>
-                  <a:txBody>
-                    <a:bodyPr/>
-                    <a:lstStyle/>
-                    <a:p>
-                      <a:r>
-                        <a:rPr sz="1050">
-                          <a:solidFill>
-                            <a:srgbClr val="3D5466"/>
-                          </a:solidFill>
-                          <a:latin typeface="Arial"/>
-                        </a:rPr>
-                        <a:t>Ratingbasiert</a:t>
-                      </a:r>
-                    </a:p>
-                  </a:txBody>
-                  <a:tcPr/>
-                </a:tc>
-                <a:tc>
-                  <a:txBody>
-                    <a:bodyPr/>
-                    <a:lstStyle/>
-                    <a:p/>
-                  </a:txBody>
-                  <a:tcPr/>
-                </a:tc>
-                <a:tc>
-                  <a:txBody>
-                    <a:bodyPr/>
-                    <a:lstStyle/>
-                    <a:p/>
-                  </a:txBody>
-                  <a:tcPr/>
-                </a:tc>
-                <a:tc>
-                  <a:txBody>
-                    <a:bodyPr/>
-                    <a:lstStyle/>
-                    <a:p/>
-                  </a:txBody>
-                  <a:tcPr/>
-                </a:tc>
-              </a:tr>
-              <a:tr h="384048">
-                <a:tc>
-                  <a:txBody>
-                    <a:bodyPr/>
-                    <a:lstStyle/>
-                    <a:p>
-                      <a:r>
-                        <a:rPr sz="1050">
-                          <a:solidFill>
-                            <a:srgbClr val="3D5466"/>
-                          </a:solidFill>
-                          <a:latin typeface="Arial"/>
-                        </a:rPr>
-                        <a:t>Lebensereignis</a:t>
-                      </a:r>
-                    </a:p>
-                  </a:txBody>
-                  <a:tcPr/>
-                </a:tc>
-                <a:tc>
-                  <a:txBody>
-                    <a:bodyPr/>
-                    <a:lstStyle/>
-                    <a:p/>
-                  </a:txBody>
-                  <a:tcPr/>
-                </a:tc>
-                <a:tc>
-                  <a:txBody>
-                    <a:bodyPr/>
-                    <a:lstStyle/>
-                    <a:p/>
-                  </a:txBody>
-                  <a:tcPr/>
-                </a:tc>
-                <a:tc>
-                  <a:txBody>
-                    <a:bodyPr/>
-                    <a:lstStyle/>
-                    <a:p/>
-                  </a:txBody>
-                  <a:tcPr/>
-                </a:tc>
-              </a:tr>
-              <a:tr h="384048">
-                <a:tc>
-                  <a:txBody>
-                    <a:bodyPr/>
-                    <a:lstStyle/>
-                    <a:p>
-                      <a:r>
-                        <a:rPr sz="1050">
-                          <a:solidFill>
-                            <a:srgbClr val="3D5466"/>
-                          </a:solidFill>
-                          <a:latin typeface="Arial"/>
-                        </a:rPr>
-                        <a:t>Lebensereignis</a:t>
-                      </a:r>
-                    </a:p>
-                  </a:txBody>
-                  <a:tcPr/>
-                </a:tc>
-                <a:tc>
-                  <a:txBody>
-                    <a:bodyPr/>
-                    <a:lstStyle/>
-                    <a:p/>
-                  </a:txBody>
-                  <a:tcPr/>
-                </a:tc>
-                <a:tc>
-                  <a:txBody>
-                    <a:bodyPr/>
-                    <a:lstStyle/>
-                    <a:p/>
-                  </a:txBody>
-                  <a:tcPr/>
-                </a:tc>
-                <a:tc>
-                  <a:txBody>
-                    <a:bodyPr/>
-                    <a:lstStyle/>
-                    <a:p/>
-                  </a:txBody>
-                  <a:tcPr/>
-                </a:tc>
-              </a:tr>
-            </a:tbl>
-          </a:graphicData>
-        </a:graphic>
-      </p:graphicFrame>
-      <p:sp>
-        <p:nvSpPr>
-          <p:cNvPr id="8" name="Rectangle 7"/>
+      <p:sp>
+        <p:nvSpPr>
+          <p:cNvPr id="7" name="TextBox 6"/>
+          <p:cNvSpPr txBox="1"/>
+          <p:nvPr/>
+        </p:nvSpPr>
+        <p:spPr>
+          <a:xfrm>
+            <a:off x="813816" y="502920"/>
+            <a:ext cx="10634472" cy="685800"/>
+          </a:xfrm>
+          <a:prstGeom prst="rect">
+            <a:avLst/>
+          </a:prstGeom>
+          <a:noFill/>
+        </p:spPr>
+        <p:txBody>
+          <a:bodyPr wrap="square">
+            <a:spAutoFit/>
+          </a:bodyPr>
+          <a:lstStyle/>
+          <a:p>
+            <a:pPr algn="l"/>
+            <a:r>
+              <a:rPr sz="2400" b="1" i="0">
+                <a:solidFill>
+                  <a:srgbClr val="1F2C56"/>
+                </a:solidFill>
+                <a:latin typeface="Arial"/>
+              </a:rPr>
+              <a:t>Reflexion und Selbstcheck</a:t>
+            </a:r>
+          </a:p>
+        </p:txBody>
+      </p:sp>
+      <p:sp>
+        <p:nvSpPr>
+          <p:cNvPr id="8" name="TextBox 7"/>
+          <p:cNvSpPr txBox="1"/>
+          <p:nvPr/>
+        </p:nvSpPr>
+        <p:spPr>
+          <a:xfrm>
+            <a:off x="685800" y="1417320"/>
+            <a:ext cx="10817352" cy="4892040"/>
+          </a:xfrm>
+          <a:prstGeom prst="rect">
+            <a:avLst/>
+          </a:prstGeom>
+          <a:noFill/>
+        </p:spPr>
+        <p:txBody>
+          <a:bodyPr wrap="square" anchor="ctr">
+            <a:spAutoFit/>
+          </a:bodyPr>
+          <a:lstStyle/>
+          <a:p>
+            <a:pPr marL="190500" indent="-190500">
+              <a:spcBef>
+                <a:spcPts val="400"/>
+              </a:spcBef>
+              <a:spcAft>
+                <a:spcPts val="200"/>
+              </a:spcAft>
+            </a:pPr>
+            <a:r>
+              <a:rPr sz="1300">
+                <a:solidFill>
+                  <a:srgbClr val="3D5466"/>
+                </a:solidFill>
+                <a:latin typeface="Arial"/>
+              </a:rPr>
+              <a:t>▸  Welcher Trigger-Typ ist in Ihrem Bestand am ungenutztesten?</a:t>
+            </a:r>
+          </a:p>
+          <a:p>
+            <a:pPr marL="190500" indent="-190500">
+              <a:spcBef>
+                <a:spcPts val="400"/>
+              </a:spcBef>
+              <a:spcAft>
+                <a:spcPts val="200"/>
+              </a:spcAft>
+            </a:pPr>
+            <a:r>
+              <a:rPr sz="1300">
+                <a:solidFill>
+                  <a:srgbClr val="3D5466"/>
+                </a:solidFill>
+                <a:latin typeface="Arial"/>
+              </a:rPr>
+              <a:t>▸  Wo sind Ihre Daten so lückenhaft, dass Trigger untergehen?</a:t>
+            </a:r>
+          </a:p>
+          <a:p>
+            <a:pPr marL="190500" indent="-190500">
+              <a:spcBef>
+                <a:spcPts val="400"/>
+              </a:spcBef>
+              <a:spcAft>
+                <a:spcPts val="200"/>
+              </a:spcAft>
+            </a:pPr>
+            <a:r>
+              <a:rPr sz="1300">
+                <a:solidFill>
+                  <a:srgbClr val="3D5466"/>
+                </a:solidFill>
+                <a:latin typeface="Arial"/>
+              </a:rPr>
+              <a:t>▸  Wie formulieren Sie einen datenbasierten Einstieg transparent und DSGVO-konform?</a:t>
+            </a:r>
+          </a:p>
+        </p:txBody>
+      </p:sp>
+      <p:sp>
+        <p:nvSpPr>
+          <p:cNvPr id="9" name="Rectangle 8"/>
           <p:cNvSpPr/>
           <p:nvPr/>
         </p:nvSpPr>
@@ -6656,7 +6096,7 @@
       </p:sp>
       <p:sp>
         <p:nvSpPr>
-          <p:cNvPr id="9" name="TextBox 8"/>
+          <p:cNvPr id="10" name="TextBox 9"/>
           <p:cNvSpPr txBox="1"/>
           <p:nvPr/>
         </p:nvSpPr>
@@ -6685,722 +6125,6 @@
                 <a:latin typeface="Consolas"/>
               </a:rPr>
               <a:t>FKB Campus  ·  M18</a:t>
-            </a:r>
-          </a:p>
-        </p:txBody>
-      </p:sp>
-      <p:sp>
-        <p:nvSpPr>
-          <p:cNvPr id="10" name="TextBox 9"/>
-          <p:cNvSpPr txBox="1"/>
-          <p:nvPr/>
-        </p:nvSpPr>
-        <p:spPr>
-          <a:xfrm>
-            <a:off x="7176211" y="6583680"/>
-            <a:ext cx="4326940" cy="256032"/>
-          </a:xfrm>
-          <a:prstGeom prst="rect">
-            <a:avLst/>
-          </a:prstGeom>
-          <a:noFill/>
-        </p:spPr>
-        <p:txBody>
-          <a:bodyPr wrap="none">
-            <a:spAutoFit/>
-          </a:bodyPr>
-          <a:lstStyle/>
-          <a:p>
-            <a:pPr algn="r"/>
-            <a:r>
-              <a:rPr sz="700">
-                <a:solidFill>
-                  <a:srgbClr val="A0B4D2"/>
-                </a:solidFill>
-                <a:latin typeface="Consolas"/>
-              </a:rPr>
-              <a:t>Übersicht</a:t>
-            </a:r>
-          </a:p>
-        </p:txBody>
-      </p:sp>
-    </p:spTree>
-  </p:cSld>
-  <p:clrMapOvr>
-    <a:masterClrMapping/>
-  </p:clrMapOvr>
-</p:sld>
-</file>
-
-<file path=ppt/slides/slide14.xml><?xml version="1.0" encoding="utf-8"?>
-<p:sld xmlns:a="http://schemas.openxmlformats.org/drawingml/2006/main" xmlns:p="http://schemas.openxmlformats.org/presentationml/2006/main" xmlns:r="http://schemas.openxmlformats.org/officeDocument/2006/relationships">
-  <p:cSld>
-    <p:spTree>
-      <p:nvGrpSpPr>
-        <p:cNvPr id="1" name=""/>
-        <p:cNvGrpSpPr/>
-        <p:nvPr/>
-      </p:nvGrpSpPr>
-      <p:grpSpPr/>
-      <p:sp>
-        <p:nvSpPr>
-          <p:cNvPr id="2" name="Rectangle 1"/>
-          <p:cNvSpPr/>
-          <p:nvPr/>
-        </p:nvSpPr>
-        <p:spPr>
-          <a:xfrm>
-            <a:off x="0" y="0"/>
-            <a:ext cx="12188952" cy="6858000"/>
-          </a:xfrm>
-          <a:prstGeom prst="rect">
-            <a:avLst/>
-          </a:prstGeom>
-          <a:solidFill>
-            <a:srgbClr val="FFFFFF"/>
-          </a:solidFill>
-          <a:ln>
-            <a:noFill/>
-          </a:ln>
-        </p:spPr>
-        <p:style>
-          <a:lnRef idx="1">
-            <a:schemeClr val="accent1"/>
-          </a:lnRef>
-          <a:fillRef idx="3">
-            <a:schemeClr val="accent1"/>
-          </a:fillRef>
-          <a:effectRef idx="2">
-            <a:schemeClr val="accent1"/>
-          </a:effectRef>
-          <a:fontRef idx="minor">
-            <a:schemeClr val="lt1"/>
-          </a:fontRef>
-        </p:style>
-        <p:txBody>
-          <a:bodyPr rtlCol="0" anchor="ctr"/>
-          <a:lstStyle/>
-          <a:p>
-            <a:pPr algn="ctr"/>
-          </a:p>
-        </p:txBody>
-      </p:sp>
-      <p:sp>
-        <p:nvSpPr>
-          <p:cNvPr id="3" name="Rectangle 2"/>
-          <p:cNvSpPr/>
-          <p:nvPr/>
-        </p:nvSpPr>
-        <p:spPr>
-          <a:xfrm>
-            <a:off x="0" y="0"/>
-            <a:ext cx="12188952" cy="50292"/>
-          </a:xfrm>
-          <a:prstGeom prst="rect">
-            <a:avLst/>
-          </a:prstGeom>
-          <a:solidFill>
-            <a:srgbClr val="1F2C56"/>
-          </a:solidFill>
-          <a:ln>
-            <a:noFill/>
-          </a:ln>
-        </p:spPr>
-        <p:style>
-          <a:lnRef idx="1">
-            <a:schemeClr val="accent1"/>
-          </a:lnRef>
-          <a:fillRef idx="3">
-            <a:schemeClr val="accent1"/>
-          </a:fillRef>
-          <a:effectRef idx="2">
-            <a:schemeClr val="accent1"/>
-          </a:effectRef>
-          <a:fontRef idx="minor">
-            <a:schemeClr val="lt1"/>
-          </a:fontRef>
-        </p:style>
-        <p:txBody>
-          <a:bodyPr rtlCol="0" anchor="ctr"/>
-          <a:lstStyle/>
-          <a:p>
-            <a:pPr algn="ctr"/>
-          </a:p>
-        </p:txBody>
-      </p:sp>
-      <p:sp>
-        <p:nvSpPr>
-          <p:cNvPr id="4" name="TextBox 3"/>
-          <p:cNvSpPr txBox="1"/>
-          <p:nvPr/>
-        </p:nvSpPr>
-        <p:spPr>
-          <a:xfrm>
-            <a:off x="685800" y="109728"/>
-            <a:ext cx="10817352" cy="228600"/>
-          </a:xfrm>
-          <a:prstGeom prst="rect">
-            <a:avLst/>
-          </a:prstGeom>
-          <a:noFill/>
-        </p:spPr>
-        <p:txBody>
-          <a:bodyPr wrap="none">
-            <a:spAutoFit/>
-          </a:bodyPr>
-          <a:lstStyle/>
-          <a:p>
-            <a:pPr algn="l"/>
-            <a:r>
-              <a:rPr sz="750">
-                <a:solidFill>
-                  <a:srgbClr val="78808C"/>
-                </a:solidFill>
-                <a:latin typeface="Consolas"/>
-              </a:rPr>
-              <a:t>M18  ·  ÜBERSICHT</a:t>
-            </a:r>
-          </a:p>
-        </p:txBody>
-      </p:sp>
-      <p:sp>
-        <p:nvSpPr>
-          <p:cNvPr id="5" name="TextBox 4"/>
-          <p:cNvSpPr txBox="1"/>
-          <p:nvPr/>
-        </p:nvSpPr>
-        <p:spPr>
-          <a:xfrm>
-            <a:off x="685800" y="502920"/>
-            <a:ext cx="10817352" cy="594360"/>
-          </a:xfrm>
-          <a:prstGeom prst="rect">
-            <a:avLst/>
-          </a:prstGeom>
-          <a:noFill/>
-        </p:spPr>
-        <p:txBody>
-          <a:bodyPr wrap="square">
-            <a:spAutoFit/>
-          </a:bodyPr>
-          <a:lstStyle/>
-          <a:p>
-            <a:pPr algn="l"/>
-            <a:r>
-              <a:rPr sz="2000" b="1" i="0">
-                <a:solidFill>
-                  <a:srgbClr val="1F2C56"/>
-                </a:solidFill>
-                <a:latin typeface="Arial"/>
-              </a:rPr>
-              <a:t>AB-2: Datenqualitäts-Audit (Top-10-Kunden)</a:t>
-            </a:r>
-          </a:p>
-        </p:txBody>
-      </p:sp>
-      <p:sp>
-        <p:nvSpPr>
-          <p:cNvPr id="6" name="Rectangle 5"/>
-          <p:cNvSpPr/>
-          <p:nvPr/>
-        </p:nvSpPr>
-        <p:spPr>
-          <a:xfrm>
-            <a:off x="685800" y="1143000"/>
-            <a:ext cx="10817352" cy="25400"/>
-          </a:xfrm>
-          <a:prstGeom prst="rect">
-            <a:avLst/>
-          </a:prstGeom>
-          <a:solidFill>
-            <a:srgbClr val="D9C089"/>
-          </a:solidFill>
-          <a:ln>
-            <a:noFill/>
-          </a:ln>
-        </p:spPr>
-        <p:style>
-          <a:lnRef idx="1">
-            <a:schemeClr val="accent1"/>
-          </a:lnRef>
-          <a:fillRef idx="3">
-            <a:schemeClr val="accent1"/>
-          </a:fillRef>
-          <a:effectRef idx="2">
-            <a:schemeClr val="accent1"/>
-          </a:effectRef>
-          <a:fontRef idx="minor">
-            <a:schemeClr val="lt1"/>
-          </a:fontRef>
-        </p:style>
-        <p:txBody>
-          <a:bodyPr rtlCol="0" anchor="ctr"/>
-          <a:lstStyle/>
-          <a:p>
-            <a:pPr algn="ctr"/>
-          </a:p>
-        </p:txBody>
-      </p:sp>
-      <p:graphicFrame>
-        <p:nvGraphicFramePr>
-          <p:cNvPr id="7" name="Table 6"/>
-          <p:cNvGraphicFramePr>
-            <a:graphicFrameLocks noGrp="1"/>
-          </p:cNvGraphicFramePr>
-          <p:nvPr/>
-        </p:nvGraphicFramePr>
-        <p:xfrm>
-          <a:off x="685800" y="1417320"/>
-          <a:ext cx="10817352" cy="2304288"/>
-        </p:xfrm>
-        <a:graphic>
-          <a:graphicData uri="http://schemas.openxmlformats.org/drawingml/2006/table">
-            <a:tbl>
-              <a:tblPr firstRow="1" bandRow="1">
-                <a:tableStyleId>{5C22544A-7EE6-4342-B048-85BDC9FD1C3A}</a:tableStyleId>
-              </a:tblPr>
-              <a:tblGrid>
-                <a:gridCol w="2163470"/>
-                <a:gridCol w="2163470"/>
-                <a:gridCol w="2163470"/>
-                <a:gridCol w="2163470"/>
-                <a:gridCol w="2163472"/>
-              </a:tblGrid>
-              <a:tr h="384048">
-                <a:tc>
-                  <a:txBody>
-                    <a:bodyPr/>
-                    <a:lstStyle/>
-                    <a:p>
-                      <a:r>
-                        <a:rPr sz="1100" b="1">
-                          <a:solidFill>
-                            <a:srgbClr val="FFFFFF"/>
-                          </a:solidFill>
-                          <a:latin typeface="Arial"/>
-                        </a:rPr>
-                        <a:t>Kunde (anonymisiert)</a:t>
-                      </a:r>
-                    </a:p>
-                  </a:txBody>
-                  <a:tcPr>
-                    <a:solidFill>
-                      <a:srgbClr val="1F2C56"/>
-                    </a:solidFill>
-                  </a:tcPr>
-                </a:tc>
-                <a:tc>
-                  <a:txBody>
-                    <a:bodyPr/>
-                    <a:lstStyle/>
-                    <a:p>
-                      <a:r>
-                        <a:rPr sz="1100" b="1">
-                          <a:solidFill>
-                            <a:srgbClr val="FFFFFF"/>
-                          </a:solidFill>
-                          <a:latin typeface="Arial"/>
-                        </a:rPr>
-                        <a:t>Geburtsdatum ✓/✗</a:t>
-                      </a:r>
-                    </a:p>
-                  </a:txBody>
-                  <a:tcPr>
-                    <a:solidFill>
-                      <a:srgbClr val="1F2C56"/>
-                    </a:solidFill>
-                  </a:tcPr>
-                </a:tc>
-                <a:tc>
-                  <a:txBody>
-                    <a:bodyPr/>
-                    <a:lstStyle/>
-                    <a:p>
-                      <a:r>
-                        <a:rPr sz="1100" b="1">
-                          <a:solidFill>
-                            <a:srgbClr val="FFFFFF"/>
-                          </a:solidFill>
-                          <a:latin typeface="Arial"/>
-                        </a:rPr>
-                        <a:t>Branche korrekt ✓/✗</a:t>
-                      </a:r>
-                    </a:p>
-                  </a:txBody>
-                  <a:tcPr>
-                    <a:solidFill>
-                      <a:srgbClr val="1F2C56"/>
-                    </a:solidFill>
-                  </a:tcPr>
-                </a:tc>
-                <a:tc>
-                  <a:txBody>
-                    <a:bodyPr/>
-                    <a:lstStyle/>
-                    <a:p>
-                      <a:r>
-                        <a:rPr sz="1100" b="1">
-                          <a:solidFill>
-                            <a:srgbClr val="FFFFFF"/>
-                          </a:solidFill>
-                          <a:latin typeface="Arial"/>
-                        </a:rPr>
-                        <a:t>JA aktuell ✓/✗</a:t>
-                      </a:r>
-                    </a:p>
-                  </a:txBody>
-                  <a:tcPr>
-                    <a:solidFill>
-                      <a:srgbClr val="1F2C56"/>
-                    </a:solidFill>
-                  </a:tcPr>
-                </a:tc>
-                <a:tc>
-                  <a:txBody>
-                    <a:bodyPr/>
-                    <a:lstStyle/>
-                    <a:p>
-                      <a:r>
-                        <a:rPr sz="1100" b="1">
-                          <a:solidFill>
-                            <a:srgbClr val="FFFFFF"/>
-                          </a:solidFill>
-                          <a:latin typeface="Arial"/>
-                        </a:rPr>
-                        <a:t>Verbund aktuell ✓/✗</a:t>
-                      </a:r>
-                    </a:p>
-                  </a:txBody>
-                  <a:tcPr>
-                    <a:solidFill>
-                      <a:srgbClr val="1F2C56"/>
-                    </a:solidFill>
-                  </a:tcPr>
-                </a:tc>
-              </a:tr>
-              <a:tr h="384048">
-                <a:tc>
-                  <a:txBody>
-                    <a:bodyPr/>
-                    <a:lstStyle/>
-                    <a:p/>
-                  </a:txBody>
-                  <a:tcPr/>
-                </a:tc>
-                <a:tc>
-                  <a:txBody>
-                    <a:bodyPr/>
-                    <a:lstStyle/>
-                    <a:p/>
-                  </a:txBody>
-                  <a:tcPr/>
-                </a:tc>
-                <a:tc>
-                  <a:txBody>
-                    <a:bodyPr/>
-                    <a:lstStyle/>
-                    <a:p/>
-                  </a:txBody>
-                  <a:tcPr/>
-                </a:tc>
-                <a:tc>
-                  <a:txBody>
-                    <a:bodyPr/>
-                    <a:lstStyle/>
-                    <a:p/>
-                  </a:txBody>
-                  <a:tcPr/>
-                </a:tc>
-                <a:tc>
-                  <a:txBody>
-                    <a:bodyPr/>
-                    <a:lstStyle/>
-                    <a:p/>
-                  </a:txBody>
-                  <a:tcPr/>
-                </a:tc>
-              </a:tr>
-              <a:tr h="384048">
-                <a:tc>
-                  <a:txBody>
-                    <a:bodyPr/>
-                    <a:lstStyle/>
-                    <a:p/>
-                  </a:txBody>
-                  <a:tcPr/>
-                </a:tc>
-                <a:tc>
-                  <a:txBody>
-                    <a:bodyPr/>
-                    <a:lstStyle/>
-                    <a:p/>
-                  </a:txBody>
-                  <a:tcPr/>
-                </a:tc>
-                <a:tc>
-                  <a:txBody>
-                    <a:bodyPr/>
-                    <a:lstStyle/>
-                    <a:p/>
-                  </a:txBody>
-                  <a:tcPr/>
-                </a:tc>
-                <a:tc>
-                  <a:txBody>
-                    <a:bodyPr/>
-                    <a:lstStyle/>
-                    <a:p/>
-                  </a:txBody>
-                  <a:tcPr/>
-                </a:tc>
-                <a:tc>
-                  <a:txBody>
-                    <a:bodyPr/>
-                    <a:lstStyle/>
-                    <a:p/>
-                  </a:txBody>
-                  <a:tcPr/>
-                </a:tc>
-              </a:tr>
-              <a:tr h="384048">
-                <a:tc>
-                  <a:txBody>
-                    <a:bodyPr/>
-                    <a:lstStyle/>
-                    <a:p/>
-                  </a:txBody>
-                  <a:tcPr/>
-                </a:tc>
-                <a:tc>
-                  <a:txBody>
-                    <a:bodyPr/>
-                    <a:lstStyle/>
-                    <a:p/>
-                  </a:txBody>
-                  <a:tcPr/>
-                </a:tc>
-                <a:tc>
-                  <a:txBody>
-                    <a:bodyPr/>
-                    <a:lstStyle/>
-                    <a:p/>
-                  </a:txBody>
-                  <a:tcPr/>
-                </a:tc>
-                <a:tc>
-                  <a:txBody>
-                    <a:bodyPr/>
-                    <a:lstStyle/>
-                    <a:p/>
-                  </a:txBody>
-                  <a:tcPr/>
-                </a:tc>
-                <a:tc>
-                  <a:txBody>
-                    <a:bodyPr/>
-                    <a:lstStyle/>
-                    <a:p/>
-                  </a:txBody>
-                  <a:tcPr/>
-                </a:tc>
-              </a:tr>
-              <a:tr h="384048">
-                <a:tc>
-                  <a:txBody>
-                    <a:bodyPr/>
-                    <a:lstStyle/>
-                    <a:p/>
-                  </a:txBody>
-                  <a:tcPr/>
-                </a:tc>
-                <a:tc>
-                  <a:txBody>
-                    <a:bodyPr/>
-                    <a:lstStyle/>
-                    <a:p/>
-                  </a:txBody>
-                  <a:tcPr/>
-                </a:tc>
-                <a:tc>
-                  <a:txBody>
-                    <a:bodyPr/>
-                    <a:lstStyle/>
-                    <a:p/>
-                  </a:txBody>
-                  <a:tcPr/>
-                </a:tc>
-                <a:tc>
-                  <a:txBody>
-                    <a:bodyPr/>
-                    <a:lstStyle/>
-                    <a:p/>
-                  </a:txBody>
-                  <a:tcPr/>
-                </a:tc>
-                <a:tc>
-                  <a:txBody>
-                    <a:bodyPr/>
-                    <a:lstStyle/>
-                    <a:p/>
-                  </a:txBody>
-                  <a:tcPr/>
-                </a:tc>
-              </a:tr>
-              <a:tr h="384048">
-                <a:tc>
-                  <a:txBody>
-                    <a:bodyPr/>
-                    <a:lstStyle/>
-                    <a:p/>
-                  </a:txBody>
-                  <a:tcPr/>
-                </a:tc>
-                <a:tc>
-                  <a:txBody>
-                    <a:bodyPr/>
-                    <a:lstStyle/>
-                    <a:p/>
-                  </a:txBody>
-                  <a:tcPr/>
-                </a:tc>
-                <a:tc>
-                  <a:txBody>
-                    <a:bodyPr/>
-                    <a:lstStyle/>
-                    <a:p/>
-                  </a:txBody>
-                  <a:tcPr/>
-                </a:tc>
-                <a:tc>
-                  <a:txBody>
-                    <a:bodyPr/>
-                    <a:lstStyle/>
-                    <a:p/>
-                  </a:txBody>
-                  <a:tcPr/>
-                </a:tc>
-                <a:tc>
-                  <a:txBody>
-                    <a:bodyPr/>
-                    <a:lstStyle/>
-                    <a:p/>
-                  </a:txBody>
-                  <a:tcPr/>
-                </a:tc>
-              </a:tr>
-            </a:tbl>
-          </a:graphicData>
-        </a:graphic>
-      </p:graphicFrame>
-      <p:sp>
-        <p:nvSpPr>
-          <p:cNvPr id="8" name="Rectangle 7"/>
-          <p:cNvSpPr/>
-          <p:nvPr/>
-        </p:nvSpPr>
-        <p:spPr>
-          <a:xfrm>
-            <a:off x="0" y="6510528"/>
-            <a:ext cx="12188952" cy="347472"/>
-          </a:xfrm>
-          <a:prstGeom prst="rect">
-            <a:avLst/>
-          </a:prstGeom>
-          <a:solidFill>
-            <a:srgbClr val="0A1937"/>
-          </a:solidFill>
-          <a:ln>
-            <a:noFill/>
-          </a:ln>
-        </p:spPr>
-        <p:style>
-          <a:lnRef idx="1">
-            <a:schemeClr val="accent1"/>
-          </a:lnRef>
-          <a:fillRef idx="3">
-            <a:schemeClr val="accent1"/>
-          </a:fillRef>
-          <a:effectRef idx="2">
-            <a:schemeClr val="accent1"/>
-          </a:effectRef>
-          <a:fontRef idx="minor">
-            <a:schemeClr val="lt1"/>
-          </a:fontRef>
-        </p:style>
-        <p:txBody>
-          <a:bodyPr rtlCol="0" anchor="ctr"/>
-          <a:lstStyle/>
-          <a:p>
-            <a:pPr algn="ctr"/>
-          </a:p>
-        </p:txBody>
-      </p:sp>
-      <p:sp>
-        <p:nvSpPr>
-          <p:cNvPr id="9" name="TextBox 8"/>
-          <p:cNvSpPr txBox="1"/>
-          <p:nvPr/>
-        </p:nvSpPr>
-        <p:spPr>
-          <a:xfrm>
-            <a:off x="685800" y="6583680"/>
-            <a:ext cx="6490411" cy="256032"/>
-          </a:xfrm>
-          <a:prstGeom prst="rect">
-            <a:avLst/>
-          </a:prstGeom>
-          <a:noFill/>
-        </p:spPr>
-        <p:txBody>
-          <a:bodyPr wrap="none">
-            <a:spAutoFit/>
-          </a:bodyPr>
-          <a:lstStyle/>
-          <a:p>
-            <a:pPr algn="l"/>
-            <a:r>
-              <a:rPr sz="700">
-                <a:solidFill>
-                  <a:srgbClr val="A0B4D2"/>
-                </a:solidFill>
-                <a:latin typeface="Consolas"/>
-              </a:rPr>
-              <a:t>FKB Campus  ·  M18</a:t>
-            </a:r>
-          </a:p>
-        </p:txBody>
-      </p:sp>
-      <p:sp>
-        <p:nvSpPr>
-          <p:cNvPr id="10" name="TextBox 9"/>
-          <p:cNvSpPr txBox="1"/>
-          <p:nvPr/>
-        </p:nvSpPr>
-        <p:spPr>
-          <a:xfrm>
-            <a:off x="7176211" y="6583680"/>
-            <a:ext cx="4326940" cy="256032"/>
-          </a:xfrm>
-          <a:prstGeom prst="rect">
-            <a:avLst/>
-          </a:prstGeom>
-          <a:noFill/>
-        </p:spPr>
-        <p:txBody>
-          <a:bodyPr wrap="none">
-            <a:spAutoFit/>
-          </a:bodyPr>
-          <a:lstStyle/>
-          <a:p>
-            <a:pPr algn="r"/>
-            <a:r>
-              <a:rPr sz="700">
-                <a:solidFill>
-                  <a:srgbClr val="A0B4D2"/>
-                </a:solidFill>
-                <a:latin typeface="Consolas"/>
-              </a:rPr>
-              <a:t>Übersicht</a:t>
             </a:r>
           </a:p>
         </p:txBody>
@@ -9155,7 +7879,7 @@
                 </a:solidFill>
                 <a:latin typeface="Arial"/>
               </a:rPr>
-              <a:t>Vom Zufallskontakt zum Signal-gesteuerten Gespräch</a:t>
+              <a:t>Ein Datenpunkt öffnet die Tür – das Gespräch bleibt menschlich</a:t>
             </a:r>
           </a:p>
         </p:txBody>
@@ -9197,7 +7921,45 @@
                 </a:solidFill>
                 <a:latin typeface="Arial"/>
               </a:rPr>
-              <a:t>→  Datengetriebener Vertrieb bedeutet nicht, Kunden zu überwachen. Es bedeutet, die Signale zu lesen, die der Kunde ohnehin sendet – und im richtigen Moment präsent zu sein.</a:t>
+              <a:t>→  Ein Datenpunkt öffnet die Tür – das Gespräch bleibt menschlich.</a:t>
+            </a:r>
+          </a:p>
+          <a:p>
+            <a:pPr marL="190500" indent="-190500">
+              <a:spcBef>
+                <a:spcPts val="400"/>
+              </a:spcBef>
+              <a:spcAft>
+                <a:spcPts val="200"/>
+              </a:spcAft>
+            </a:pPr>
+            <a:r>
+              <a:rPr sz="1300">
+                <a:solidFill>
+                  <a:srgbClr val="3D5466"/>
+                </a:solidFill>
+                <a:latin typeface="Arial"/>
+              </a:rPr>
+              <a:t>▸  Trigger aus agree machen aus dem Kaltanruf einen Anlass.</a:t>
+            </a:r>
+          </a:p>
+          <a:p>
+            <a:pPr marL="190500" indent="-190500">
+              <a:spcBef>
+                <a:spcPts val="400"/>
+              </a:spcBef>
+              <a:spcAft>
+                <a:spcPts val="200"/>
+              </a:spcAft>
+            </a:pPr>
+            <a:r>
+              <a:rPr sz="1300">
+                <a:solidFill>
+                  <a:srgbClr val="3D5466"/>
+                </a:solidFill>
+                <a:latin typeface="Arial"/>
+              </a:rPr>
+              <a:t>▸  Die Beziehung entsteht trotzdem am Telefon, nicht in der Software.</a:t>
             </a:r>
           </a:p>
         </p:txBody>
@@ -9535,7 +8297,7 @@
                 </a:solidFill>
                 <a:latin typeface="Arial"/>
               </a:rPr>
-              <a:t>Die drei Grundprinzipien</a:t>
+              <a:t>Vom Zufallskontakt zum signalgesteuerten Gespräch</a:t>
             </a:r>
           </a:p>
         </p:txBody>
@@ -9561,6 +8323,25 @@
             <a:spAutoFit/>
           </a:bodyPr>
           <a:lstStyle/>
+          <a:p>
+            <a:pPr marL="177800" indent="-177800">
+              <a:spcBef>
+                <a:spcPts val="600"/>
+              </a:spcBef>
+              <a:spcAft>
+                <a:spcPts val="200"/>
+              </a:spcAft>
+            </a:pPr>
+            <a:r>
+              <a:rPr sz="1200" i="1">
+                <a:solidFill>
+                  <a:srgbClr val="3D5466"/>
+                </a:solidFill>
+                <a:latin typeface="Arial"/>
+              </a:rPr>
+              <a:t>→  Datengetriebener Vertrieb ersetzt den Zufall durch das Signal – der richtige Kunde zur richtigen Zeit.</a:t>
+            </a:r>
+          </a:p>
           <a:p>
             <a:pPr marL="190500" indent="-190500">
               <a:spcBef>
@@ -9577,7 +8358,7 @@
                 </a:solidFill>
                 <a:latin typeface="Arial"/>
               </a:rPr>
-              <a:t>▸  Timing schlägt Häufigkeit: Ein Anruf zum richtigen Moment ist wertvoller als zehn Anrufe zum falschen Zeitpunkt.</a:t>
+              <a:t>▸  Drei Grundprinzipien: Signal statt Zufall, Relevanz statt Masse, Anlass statt Angebot.</a:t>
             </a:r>
           </a:p>
           <a:p>
@@ -9596,64 +8377,7 @@
                 </a:solidFill>
                 <a:latin typeface="Arial"/>
               </a:rPr>
-              <a:t>▸  Relevanz schlägt Breite: Ein auf den aktuellen Bedarf zugeschnittenes Gespräch überzeugt mehr als eine generische Produktpräsentation.</a:t>
-            </a:r>
-          </a:p>
-          <a:p>
-            <a:pPr marL="190500" indent="-190500">
-              <a:spcBef>
-                <a:spcPts val="400"/>
-              </a:spcBef>
-              <a:spcAft>
-                <a:spcPts val="200"/>
-              </a:spcAft>
-            </a:pPr>
-            <a:r>
-              <a:rPr sz="1300">
-                <a:solidFill>
-                  <a:srgbClr val="3D5466"/>
-                </a:solidFill>
-                <a:latin typeface="Arial"/>
-              </a:rPr>
-              <a:t>▸  Daten sind kein Ersatz für Beziehung: Trigger öffnen die Tür – das Gespräch selbst bleibt menschlich.</a:t>
-            </a:r>
-          </a:p>
-          <a:p>
-            <a:pPr marL="190500" indent="-190500">
-              <a:spcBef>
-                <a:spcPts val="400"/>
-              </a:spcBef>
-              <a:spcAft>
-                <a:spcPts val="200"/>
-              </a:spcAft>
-            </a:pPr>
-            <a:r>
-              <a:rPr sz="1300">
-                <a:solidFill>
-                  <a:srgbClr val="3D5466"/>
-                </a:solidFill>
-                <a:latin typeface="Arial"/>
-              </a:rPr>
-              <a:t>▸  ## 4.2 Trigger-Ereignisse: Drei Typen mit unterschiedlicher Logik</a:t>
-            </a:r>
-          </a:p>
-          <a:p>
-            <a:pPr marL="190500" indent="-190500">
-              <a:spcBef>
-                <a:spcPts val="400"/>
-              </a:spcBef>
-              <a:spcAft>
-                <a:spcPts val="200"/>
-              </a:spcAft>
-            </a:pPr>
-            <a:r>
-              <a:rPr sz="1300">
-                <a:solidFill>
-                  <a:srgbClr val="3D5466"/>
-                </a:solidFill>
-                <a:latin typeface="Arial"/>
-              </a:rPr>
-              <a:t>▸  Ein Trigger ist ein Datenpunkt oder ein Ereignis, das mit hoher Wahrscheinlichkeit auf einen aktuellen oder bevorstehenden Beratungsbedarf hinweist. Es gibt drei Typen:</a:t>
+              <a:t>▸  Der Trigger ist der Türöffner, nicht das Verkaufsargument.</a:t>
             </a:r>
           </a:p>
         </p:txBody>
@@ -9991,7 +8715,7 @@
                 </a:solidFill>
                 <a:latin typeface="Arial"/>
               </a:rPr>
-              <a:t>Typ 3: Lebensereignisbasierte Trigger (aus CRM-Notizen, externen Quellen)</a:t>
+              <a:t>Drei Trigger-Typen mit unterschiedlicher Logik</a:t>
             </a:r>
           </a:p>
         </p:txBody>
@@ -10017,6 +8741,25 @@
             <a:spAutoFit/>
           </a:bodyPr>
           <a:lstStyle/>
+          <a:p>
+            <a:pPr marL="177800" indent="-177800">
+              <a:spcBef>
+                <a:spcPts val="600"/>
+              </a:spcBef>
+              <a:spcAft>
+                <a:spcPts val="200"/>
+              </a:spcAft>
+            </a:pPr>
+            <a:r>
+              <a:rPr sz="1200" i="1">
+                <a:solidFill>
+                  <a:srgbClr val="3D5466"/>
+                </a:solidFill>
+                <a:latin typeface="Arial"/>
+              </a:rPr>
+              <a:t>→  Nicht jeder Trigger ist gleich – transaktional, ratingbasiert und lebensereignisbasiert brauchen unterschiedliche Ansprache.</a:t>
+            </a:r>
+          </a:p>
           <a:p>
             <a:pPr marL="190500" indent="-190500">
               <a:spcBef>
@@ -10033,7 +8776,7 @@
                 </a:solidFill>
                 <a:latin typeface="Arial"/>
               </a:rPr>
-              <a:t>▸  ## 4.3 Datenqualität: Die Voraussetzung für alles</a:t>
+              <a:t>▸  Transaktional (aus agree-Kontodaten): Zahlungseingänge, Liquiditätssprünge.</a:t>
             </a:r>
           </a:p>
           <a:p>
@@ -10052,7 +8795,7 @@
                 </a:solidFill>
                 <a:latin typeface="Arial"/>
               </a:rPr>
-              <a:t>▸  Datengetriebener Vertrieb funktioniert nur, wenn die Datenbasis stimmt. Die häufigsten Qualitätsmängel:</a:t>
+              <a:t>▸  Ratingbasiert (aus Kreditakte/Frühwarnsystem): Veränderungen im Risikobild.</a:t>
             </a:r>
           </a:p>
           <a:p>
@@ -10071,7 +8814,7 @@
                 </a:solidFill>
                 <a:latin typeface="Arial"/>
               </a:rPr>
-              <a:t>▸  Faustregel: Daten, die älter als 18 Monate sind, ohne Update, sind für trigger-basierten Vertrieb unzuverlässig.</a:t>
+              <a:t>▸  Lebensereignisbasiert (aus CRM/externen Quellen): Nachfolge, Investition, Wechsel.</a:t>
             </a:r>
           </a:p>
         </p:txBody>
@@ -10763,7 +9506,7 @@
                 </a:solidFill>
                 <a:latin typeface="Arial"/>
               </a:rPr>
-              <a:t>Datenqualitäts-Audit im eigenen Bestand</a:t>
+              <a:t>Datenqualität und DSGVO: die Voraussetzung</a:t>
             </a:r>
           </a:p>
         </p:txBody>
@@ -10789,6 +9532,25 @@
             <a:spAutoFit/>
           </a:bodyPr>
           <a:lstStyle/>
+          <a:p>
+            <a:pPr marL="177800" indent="-177800">
+              <a:spcBef>
+                <a:spcPts val="600"/>
+              </a:spcBef>
+              <a:spcAft>
+                <a:spcPts val="200"/>
+              </a:spcAft>
+            </a:pPr>
+            <a:r>
+              <a:rPr sz="1200" i="1">
+                <a:solidFill>
+                  <a:srgbClr val="3D5466"/>
+                </a:solidFill>
+                <a:latin typeface="Arial"/>
+              </a:rPr>
+              <a:t>→  Datengetriebener Vertrieb steht und fällt mit der Datenqualität – und mit der Rechtssicherheit.</a:t>
+            </a:r>
+          </a:p>
           <a:p>
             <a:pPr marL="190500" indent="-190500">
               <a:spcBef>
@@ -10805,7 +9567,7 @@
                 </a:solidFill>
                 <a:latin typeface="Arial"/>
               </a:rPr>
-              <a:t>▸  Führen Sie einmalig pro Jahr einen strukturierten Datencheck durch:</a:t>
+              <a:t>▸  Datenqualitäts-Audit im eigenen Bestand: Lücken sichtbar machen.</a:t>
             </a:r>
           </a:p>
           <a:p>
@@ -10824,7 +9586,7 @@
                 </a:solidFill>
                 <a:latin typeface="Arial"/>
               </a:rPr>
-              <a:t>▸  In agree eine Bestandsliste Ihrer Firmenkunden aufrufen (Weg je nach Bankinstallation: Bestandsbetreuer-Cockpit oder Listenabfrage über agree-Auswertungskomponente – lassen Sie sich das einmalig von Ihrem IT-Koordinator zeigen, da ein standardisierter „Lückenanalyse"-Menüpunkt nicht in jeder Installation verfügbar ist). Alternativ: Export als Excel aus dem Bestandscockpit und manuelle Filterung.</a:t>
+              <a:t>▸  DSGVO: was erlaubt ist, was nicht; Verbundpartner-Einwilligung als Pflichtcheck vor jeder Übergabe.</a:t>
             </a:r>
           </a:p>
           <a:p>
@@ -10843,45 +9605,7 @@
                 </a:solidFill>
                 <a:latin typeface="Arial"/>
               </a:rPr>
-              <a:t>▸  Für alle Kunden mit &gt; 500k Kreditvolumen prüfen: Geburtsdatum, Branche, Gesellschafterstruktur, Jahresabschluss-Datum (Arbeitsblatt B als Checkliste nutzen)</a:t>
-            </a:r>
-          </a:p>
-          <a:p>
-            <a:pPr marL="190500" indent="-190500">
-              <a:spcBef>
-                <a:spcPts val="400"/>
-              </a:spcBef>
-              <a:spcAft>
-                <a:spcPts val="200"/>
-              </a:spcAft>
-            </a:pPr>
-            <a:r>
-              <a:rPr sz="1300">
-                <a:solidFill>
-                  <a:srgbClr val="3D5466"/>
-                </a:solidFill>
-                <a:latin typeface="Arial"/>
-              </a:rPr>
-              <a:t>▸  Fehler in den nächsten drei Kundengesprächen schließen (gezielt im Gespräch erfragen)</a:t>
-            </a:r>
-          </a:p>
-          <a:p>
-            <a:pPr marL="190500" indent="-190500">
-              <a:spcBef>
-                <a:spcPts val="400"/>
-              </a:spcBef>
-              <a:spcAft>
-                <a:spcPts val="200"/>
-              </a:spcAft>
-            </a:pPr>
-            <a:r>
-              <a:rPr sz="1300">
-                <a:solidFill>
-                  <a:srgbClr val="3D5466"/>
-                </a:solidFill>
-                <a:latin typeface="Arial"/>
-              </a:rPr>
-              <a:t>▸  ## 4.4 DSGVO-konforme Datennutzung im Vertrieb</a:t>
+              <a:t>▸  Transparenz gegenüber dem Kunden ist ein Vertrauensmoment, kein Risiko.</a:t>
             </a:r>
           </a:p>
         </p:txBody>

</xml_diff>